<commit_message>
sd-11-009, sd-11-010: recompute the heartbeat simulation, fix the time-scale wording
Co-Authored-By: Claude Sonnet 5.5 <noreply@anthropic.com>
Claude-Session: https://claude.ai/code/session_0121Z35eF2EmPsW9asDgHWsZ
</commit_message>
<xml_diff>
--- a/system-design-101/vi/lessons/sd-11-009/slides/sd-11-009.pptx
+++ b/system-design-101/vi/lessons/sd-11-009/slides/sd-11-009.pptx
@@ -10648,7 +10648,7 @@
       </p:sp>
       <p:sp>
         <p:nvSpPr>
-          <p:cNvPr id="7" name="Text richtext-1792422018455-291768000"/>
+          <p:cNvPr id="7" name="Text 5"/>
           <p:cNvSpPr/>
           <p:nvPr/>
         </p:nvSpPr>
@@ -10667,13 +10667,11 @@
           <a:bodyPr wrap="square" lIns="0" tIns="0" rIns="0" bIns="0" rtlCol="0" anchor="ctr"/>
           <a:lstStyle/>
           <a:p>
-            <a:pPr algn="l" marL="323850" indent="-231371">
+            <a:pPr algn="l" indent="0" marL="0">
               <a:spcAft>
                 <a:spcPts val="1050"/>
               </a:spcAft>
-              <a:buSzPct val="100000"/>
-              <a:buFont typeface="Arial"/>
-              <a:buChar char="•"/>
+              <a:buNone/>
             </a:pPr>
             <a:r>
               <a:rPr lang="en-US" sz="2550" dirty="0" spc="-2" kern="0">
@@ -10709,7 +10707,7 @@
               <a:t> khoảng</a:t>
             </a:r>
             <a:r>
-              <a:rPr lang="en-US" sz="2550" dirty="0" spc="-3" kern="0">
+              <a:rPr lang="en-US" sz="2550" dirty="0" spc="-27" kern="0">
                 <a:solidFill>
                   <a:srgbClr val="E4E1D8"/>
                 </a:solidFill>
@@ -10717,7 +10715,7 @@
                 <a:ea typeface="Be Vietnam Pro" pitchFamily="34" charset="-122"/>
                 <a:cs typeface="Be Vietnam Pro" pitchFamily="34" charset="-120"/>
               </a:rPr>
-              <a:t> 12,5</a:t>
+              <a:t> 24</a:t>
             </a:r>
             <a:r>
               <a:rPr lang="en-US" sz="2550" dirty="0" spc="0" kern="0">
@@ -10733,13 +10731,11 @@
             <a:endParaRPr lang="en-US" sz="2550" dirty="0"/>
           </a:p>
           <a:p>
-            <a:pPr algn="l" marL="323850" indent="-231371">
+            <a:pPr algn="l" indent="0" marL="0">
               <a:spcAft>
                 <a:spcPts val="1050"/>
               </a:spcAft>
-              <a:buSzPct val="100000"/>
-              <a:buFont typeface="Arial"/>
-              <a:buChar char="•"/>
+              <a:buNone/>
             </a:pPr>
             <a:r>
               <a:rPr lang="en-US" sz="2550" dirty="0" spc="-5" kern="0">
@@ -10753,7 +10749,7 @@
               <a:t>3 giây:</a:t>
             </a:r>
             <a:r>
-              <a:rPr lang="en-US" sz="2550" dirty="0" spc="-2" kern="0">
+              <a:rPr lang="en-US" sz="2550" dirty="0" spc="-3" kern="0">
                 <a:solidFill>
                   <a:srgbClr val="E4E1D8"/>
                 </a:solidFill>
@@ -10761,10 +10757,10 @@
                 <a:ea typeface="Be Vietnam Pro" pitchFamily="34" charset="-122"/>
                 <a:cs typeface="Be Vietnam Pro" pitchFamily="34" charset="-120"/>
               </a:rPr>
-              <a:t> hai</a:t>
-            </a:r>
-            <a:r>
-              <a:rPr lang="en-US" sz="2550" dirty="0" spc="1" kern="0">
+              <a:t> 492</a:t>
+            </a:r>
+            <a:r>
+              <a:rPr lang="en-US" sz="2550" dirty="0" spc="0" kern="0">
                 <a:solidFill>
                   <a:srgbClr val="E4E1D8"/>
                 </a:solidFill>
@@ -10775,7 +10771,7 @@
               <a:t> lần</a:t>
             </a:r>
             <a:r>
-              <a:rPr lang="en-US" sz="2550" dirty="0" spc="-17" kern="0">
+              <a:rPr lang="en-US" sz="2550" dirty="0" spc="-16" kern="0">
                 <a:solidFill>
                   <a:srgbClr val="E4E1D8"/>
                 </a:solidFill>
@@ -10786,7 +10782,7 @@
               <a:t> trong</a:t>
             </a:r>
             <a:r>
-              <a:rPr lang="en-US" sz="2550" dirty="0" spc="-3" kern="0">
+              <a:rPr lang="en-US" sz="2550" dirty="0" spc="-4" kern="0">
                 <a:solidFill>
                   <a:srgbClr val="E4E1D8"/>
                 </a:solidFill>
@@ -10810,10 +10806,8 @@
             <a:endParaRPr lang="en-US" sz="2550" dirty="0"/>
           </a:p>
           <a:p>
-            <a:pPr algn="l" marL="323850" indent="-231371">
-              <a:buSzPct val="100000"/>
-              <a:buFont typeface="Arial"/>
-              <a:buChar char="•"/>
+            <a:pPr algn="l" indent="0" marL="0">
+              <a:buNone/>
             </a:pPr>
             <a:r>
               <a:rPr lang="en-US" sz="2550" dirty="0" spc="-5" kern="0">

</xml_diff>

<commit_message>
sd-11-009: measure gaps between arrivals sorted by arrival time
Co-Authored-By: Claude Sonnet 5.5 <noreply@anthropic.com>
Claude-Session: https://claude.ai/code/session_0121Z35eF2EmPsW9asDgHWsZ
</commit_message>
<xml_diff>
--- a/system-design-101/vi/lessons/sd-11-009/slides/sd-11-009.pptx
+++ b/system-design-101/vi/lessons/sd-11-009/slides/sd-11-009.pptx
@@ -10707,7 +10707,7 @@
               <a:t> khoảng</a:t>
             </a:r>
             <a:r>
-              <a:rPr lang="en-US" sz="2550" dirty="0" spc="-27" kern="0">
+              <a:rPr lang="en-US" sz="2550" dirty="0" spc="-3" kern="0">
                 <a:solidFill>
                   <a:srgbClr val="E4E1D8"/>
                 </a:solidFill>
@@ -10715,7 +10715,7 @@
                 <a:ea typeface="Be Vietnam Pro" pitchFamily="34" charset="-122"/>
                 <a:cs typeface="Be Vietnam Pro" pitchFamily="34" charset="-120"/>
               </a:rPr>
-              <a:t> 24</a:t>
+              <a:t> 12,5</a:t>
             </a:r>
             <a:r>
               <a:rPr lang="en-US" sz="2550" dirty="0" spc="0" kern="0">
@@ -10749,40 +10749,40 @@
               <a:t>3 giây:</a:t>
             </a:r>
             <a:r>
+              <a:rPr lang="en-US" sz="2550" dirty="0" spc="-2" kern="0">
+                <a:solidFill>
+                  <a:srgbClr val="E4E1D8"/>
+                </a:solidFill>
+                <a:latin typeface="Be Vietnam Pro" pitchFamily="34" charset="0"/>
+                <a:ea typeface="Be Vietnam Pro" pitchFamily="34" charset="-122"/>
+                <a:cs typeface="Be Vietnam Pro" pitchFamily="34" charset="-120"/>
+              </a:rPr>
+              <a:t> hai</a:t>
+            </a:r>
+            <a:r>
+              <a:rPr lang="en-US" sz="2550" dirty="0" spc="1" kern="0">
+                <a:solidFill>
+                  <a:srgbClr val="E4E1D8"/>
+                </a:solidFill>
+                <a:latin typeface="Be Vietnam Pro" pitchFamily="34" charset="0"/>
+                <a:ea typeface="Be Vietnam Pro" pitchFamily="34" charset="-122"/>
+                <a:cs typeface="Be Vietnam Pro" pitchFamily="34" charset="-120"/>
+              </a:rPr>
+              <a:t> lần</a:t>
+            </a:r>
+            <a:r>
+              <a:rPr lang="en-US" sz="2550" dirty="0" spc="-17" kern="0">
+                <a:solidFill>
+                  <a:srgbClr val="E4E1D8"/>
+                </a:solidFill>
+                <a:latin typeface="Be Vietnam Pro" pitchFamily="34" charset="0"/>
+                <a:ea typeface="Be Vietnam Pro" pitchFamily="34" charset="-122"/>
+                <a:cs typeface="Be Vietnam Pro" pitchFamily="34" charset="-120"/>
+              </a:rPr>
+              <a:t> trong</a:t>
+            </a:r>
+            <a:r>
               <a:rPr lang="en-US" sz="2550" dirty="0" spc="-3" kern="0">
-                <a:solidFill>
-                  <a:srgbClr val="E4E1D8"/>
-                </a:solidFill>
-                <a:latin typeface="Be Vietnam Pro" pitchFamily="34" charset="0"/>
-                <a:ea typeface="Be Vietnam Pro" pitchFamily="34" charset="-122"/>
-                <a:cs typeface="Be Vietnam Pro" pitchFamily="34" charset="-120"/>
-              </a:rPr>
-              <a:t> 492</a:t>
-            </a:r>
-            <a:r>
-              <a:rPr lang="en-US" sz="2550" dirty="0" spc="0" kern="0">
-                <a:solidFill>
-                  <a:srgbClr val="E4E1D8"/>
-                </a:solidFill>
-                <a:latin typeface="Be Vietnam Pro" pitchFamily="34" charset="0"/>
-                <a:ea typeface="Be Vietnam Pro" pitchFamily="34" charset="-122"/>
-                <a:cs typeface="Be Vietnam Pro" pitchFamily="34" charset="-120"/>
-              </a:rPr>
-              <a:t> lần</a:t>
-            </a:r>
-            <a:r>
-              <a:rPr lang="en-US" sz="2550" dirty="0" spc="-16" kern="0">
-                <a:solidFill>
-                  <a:srgbClr val="E4E1D8"/>
-                </a:solidFill>
-                <a:latin typeface="Be Vietnam Pro" pitchFamily="34" charset="0"/>
-                <a:ea typeface="Be Vietnam Pro" pitchFamily="34" charset="-122"/>
-                <a:cs typeface="Be Vietnam Pro" pitchFamily="34" charset="-120"/>
-              </a:rPr>
-              <a:t> trong</a:t>
-            </a:r>
-            <a:r>
-              <a:rPr lang="en-US" sz="2550" dirty="0" spc="-4" kern="0">
                 <a:solidFill>
                   <a:srgbClr val="E4E1D8"/>
                 </a:solidFill>

</xml_diff>